<commit_message>
Edit manuscript, slides and documentation for plainer prose
Replaces bold run-in labels with subheadings, removes dashes and staged
openers, and states the emoji and translation findings directly. No
numbers or claims changed; the manuscript is still filled from the
saved results.
</commit_message>
<xml_diff>
--- a/FINAL_PROJECT_22128981_GideonElormGlago_slides.pptx
+++ b/FINAL_PROJECT_22128981_GideonElormGlago_slides.pptx
@@ -3424,7 +3424,7 @@
               </a:defRPr>
             </a:pPr>
             <a:r>
-              <a:t>Without emoji, the English model calls 95% of tweets neutral: it reads the emoji, not the Twi.</a:t>
+              <a:t>Without emoji, the English model calls 95% of tweets neutral, so its other calls come mostly from emoji.</a:t>
             </a:r>
           </a:p>
           <a:p>
@@ -3993,7 +3993,7 @@
               </a:defRPr>
             </a:pPr>
             <a:r>
-              <a:t>A student in Accra would reasonably conclude the tooling problem is solved. This project checks what those claims deliver on Twi as people write it online.</a:t>
+              <a:t>From Accra, it looks as if the tools exist. This project checks what they do with Twi as people write it online.</a:t>
             </a:r>
           </a:p>
         </p:txBody>
@@ -6554,7 +6554,7 @@
               </a:defRPr>
             </a:pPr>
             <a:r>
-              <a:t>Nothing in its output signals a problem.</a:t>
+              <a:t>Its output carries no warning that anything went wrong.</a:t>
             </a:r>
           </a:p>
         </p:txBody>

</xml_diff>

<commit_message>
Update slides with the tested causes
</commit_message>
<xml_diff>
--- a/FINAL_PROJECT_22128981_GideonElormGlago_slides.pptx
+++ b/FINAL_PROJECT_22128981_GideonElormGlago_slides.pptx
@@ -3394,7 +3394,7 @@
               </a:defRPr>
             </a:pPr>
             <a:r>
-              <a:t>NLLB leaves "3"-spellings untranslated in 188 of 387 tweets that use them.</a:t>
+              <a:t>Changing only the declared source (twi_Latn vs aka_Latn) changes the translation of 829 of 949 tweets and the final label of 243.</a:t>
             </a:r>
           </a:p>
           <a:p>
@@ -3409,7 +3409,7 @@
               </a:defRPr>
             </a:pPr>
             <a:r>
-              <a:t>Changing only the declared source (twi_Latn vs aka_Latn) changes the translation of 829 of 949 tweets and the final label of 243.</a:t>
+              <a:t>Tested by removing emoji: 98 of the English model's 125 non-neutral calls on emoji tweets turn neutral.</a:t>
             </a:r>
           </a:p>
           <a:p>
@@ -3424,7 +3424,7 @@
               </a:defRPr>
             </a:pPr>
             <a:r>
-              <a:t>Without emoji, the English model calls 95% of tweets neutral, so its other calls come mostly from emoji.</a:t>
+              <a:t>Rewriting 3 as ɛ stops NLLB copying it but does not significantly help the pipeline (p = 0.76); it does help XLM-T (p = 0.027).</a:t>
             </a:r>
           </a:p>
           <a:p>
@@ -3763,7 +3763,7 @@
               </a:defRPr>
             </a:pPr>
             <a:r>
-              <a:t>A model trained on that corpus beats every system that claims broader coverage.</a:t>
+              <a:t>On that corpus, a small model trained on Twi scored far above every off-the-shelf system tested.</a:t>
             </a:r>
           </a:p>
           <a:p>
@@ -6231,7 +6231,7 @@
               </a:defRPr>
             </a:pPr>
             <a:r>
-              <a:t>A small model trained on Twi beats every system that claims Twi</a:t>
+              <a:t>A small model trained on Twi beats every off-the-shelf system tested</a:t>
             </a:r>
           </a:p>
         </p:txBody>

</xml_diff>